<commit_message>
Actualizacion extraccion datos y figuras
</commit_message>
<xml_diff>
--- a/presentacion/Presentacion.pptx
+++ b/presentacion/Presentacion.pptx
@@ -12,16 +12,16 @@
     <p:sldId id="259" r:id="rId3"/>
     <p:sldId id="257" r:id="rId4"/>
     <p:sldId id="258" r:id="rId5"/>
-    <p:sldId id="260" r:id="rId6"/>
-    <p:sldId id="261" r:id="rId7"/>
+    <p:sldId id="268" r:id="rId6"/>
+    <p:sldId id="269" r:id="rId7"/>
     <p:sldId id="262" r:id="rId8"/>
     <p:sldId id="263" r:id="rId9"/>
     <p:sldId id="264" r:id="rId10"/>
-    <p:sldId id="265" r:id="rId11"/>
-    <p:sldId id="266" r:id="rId12"/>
-    <p:sldId id="267" r:id="rId13"/>
-    <p:sldId id="268" r:id="rId14"/>
-    <p:sldId id="269" r:id="rId15"/>
+    <p:sldId id="260" r:id="rId11"/>
+    <p:sldId id="265" r:id="rId12"/>
+    <p:sldId id="261" r:id="rId13"/>
+    <p:sldId id="266" r:id="rId14"/>
+    <p:sldId id="267" r:id="rId15"/>
     <p:sldId id="270" r:id="rId16"/>
   </p:sldIdLst>
   <p:sldSz cx="12192000" cy="6858000"/>
@@ -211,7 +211,7 @@
           <a:p>
             <a:fld id="{C31B80E0-2FA0-4660-8D5F-4F957D0CB245}" type="datetimeFigureOut">
               <a:rPr lang="es-ES" smtClean="0"/>
-              <a:t>12/05/2025</a:t>
+              <a:t>13/05/2025</a:t>
             </a:fld>
             <a:endParaRPr lang="es-ES"/>
           </a:p>
@@ -709,7 +709,7 @@
           <a:p>
             <a:fld id="{B1C3AB0B-222F-4DB0-ADC9-B2167430BF50}" type="datetime1">
               <a:rPr lang="es-ES" smtClean="0"/>
-              <a:t>12/05/2025</a:t>
+              <a:t>13/05/2025</a:t>
             </a:fld>
             <a:endParaRPr lang="es-ES"/>
           </a:p>
@@ -910,7 +910,7 @@
           <a:p>
             <a:fld id="{EAD1A03F-1140-4EC3-825A-64621D76B6D4}" type="datetime1">
               <a:rPr lang="es-ES" smtClean="0"/>
-              <a:t>12/05/2025</a:t>
+              <a:t>13/05/2025</a:t>
             </a:fld>
             <a:endParaRPr lang="es-ES"/>
           </a:p>
@@ -1121,7 +1121,7 @@
           <a:p>
             <a:fld id="{9C2A3F48-89E8-499E-831F-03DB54D9BBB5}" type="datetime1">
               <a:rPr lang="es-ES" smtClean="0"/>
-              <a:t>12/05/2025</a:t>
+              <a:t>13/05/2025</a:t>
             </a:fld>
             <a:endParaRPr lang="es-ES"/>
           </a:p>
@@ -1374,7 +1374,7 @@
           <a:p>
             <a:fld id="{B4703AE7-BB3E-48DA-89E5-0943B3B46801}" type="datetime1">
               <a:rPr lang="es-ES" smtClean="0"/>
-              <a:t>12/05/2025</a:t>
+              <a:t>13/05/2025</a:t>
             </a:fld>
             <a:endParaRPr lang="es-ES"/>
           </a:p>
@@ -1714,7 +1714,7 @@
           <a:p>
             <a:fld id="{9EFAA296-26B6-48CC-B5E2-ED5B7F74E46E}" type="datetime1">
               <a:rPr lang="es-ES" smtClean="0"/>
-              <a:t>12/05/2025</a:t>
+              <a:t>13/05/2025</a:t>
             </a:fld>
             <a:endParaRPr lang="es-ES"/>
           </a:p>
@@ -1982,7 +1982,7 @@
           <a:p>
             <a:fld id="{090FE526-78A4-45FE-85D2-48F854AC25EB}" type="datetime1">
               <a:rPr lang="es-ES" smtClean="0"/>
-              <a:t>12/05/2025</a:t>
+              <a:t>13/05/2025</a:t>
             </a:fld>
             <a:endParaRPr lang="es-ES"/>
           </a:p>
@@ -2397,7 +2397,7 @@
           <a:p>
             <a:fld id="{125F1B9E-ED96-402A-A0A5-D7D0129D2590}" type="datetime1">
               <a:rPr lang="es-ES" smtClean="0"/>
-              <a:t>12/05/2025</a:t>
+              <a:t>13/05/2025</a:t>
             </a:fld>
             <a:endParaRPr lang="es-ES"/>
           </a:p>
@@ -2541,7 +2541,7 @@
           <a:p>
             <a:fld id="{F15D918A-A1FA-4CF3-84F4-FBACE0E64B02}" type="datetime1">
               <a:rPr lang="es-ES" smtClean="0"/>
-              <a:t>12/05/2025</a:t>
+              <a:t>13/05/2025</a:t>
             </a:fld>
             <a:endParaRPr lang="es-ES"/>
           </a:p>
@@ -2657,7 +2657,7 @@
           <a:p>
             <a:fld id="{A48D7788-CE1E-44AD-B7D7-1BC7EC977E65}" type="datetime1">
               <a:rPr lang="es-ES" smtClean="0"/>
-              <a:t>12/05/2025</a:t>
+              <a:t>13/05/2025</a:t>
             </a:fld>
             <a:endParaRPr lang="es-ES"/>
           </a:p>
@@ -2971,7 +2971,7 @@
           <a:p>
             <a:fld id="{D5E4CFBC-9A35-472A-8EFF-AD55C9488815}" type="datetime1">
               <a:rPr lang="es-ES" smtClean="0"/>
-              <a:t>12/05/2025</a:t>
+              <a:t>13/05/2025</a:t>
             </a:fld>
             <a:endParaRPr lang="es-ES"/>
           </a:p>
@@ -3262,7 +3262,7 @@
           <a:p>
             <a:fld id="{2559474E-732D-47ED-88BE-733A0AC2EA6B}" type="datetime1">
               <a:rPr lang="es-ES" smtClean="0"/>
-              <a:t>12/05/2025</a:t>
+              <a:t>13/05/2025</a:t>
             </a:fld>
             <a:endParaRPr lang="es-ES"/>
           </a:p>
@@ -3506,7 +3506,7 @@
           <a:p>
             <a:fld id="{886B8964-A04A-4168-BCAC-72BBFA244AE7}" type="datetime1">
               <a:rPr lang="es-ES" smtClean="0"/>
-              <a:t>12/05/2025</a:t>
+              <a:t>13/05/2025</a:t>
             </a:fld>
             <a:endParaRPr lang="es-ES"/>
           </a:p>
@@ -4557,6 +4557,216 @@
           <p:cNvPr id="2" name="Título 1">
             <a:extLst>
               <a:ext uri="{FF2B5EF4-FFF2-40B4-BE49-F238E27FC236}">
+                <a16:creationId xmlns:a16="http://schemas.microsoft.com/office/drawing/2014/main" id="{E6B63943-A4BA-B93C-B1BB-37552196A028}"/>
+              </a:ext>
+            </a:extLst>
+          </p:cNvPr>
+          <p:cNvSpPr>
+            <a:spLocks noGrp="1"/>
+          </p:cNvSpPr>
+          <p:nvPr>
+            <p:ph type="title"/>
+          </p:nvPr>
+        </p:nvSpPr>
+        <p:spPr>
+          <a:xfrm>
+            <a:off x="838200" y="-133907"/>
+            <a:ext cx="10515600" cy="1325563"/>
+          </a:xfrm>
+        </p:spPr>
+        <p:txBody>
+          <a:bodyPr/>
+          <a:lstStyle/>
+          <a:p>
+            <a:r>
+              <a:rPr lang="es-419" dirty="0">
+                <a:latin typeface="Times New Roman" panose="02020603050405020304" pitchFamily="18" charset="0"/>
+                <a:cs typeface="Times New Roman" panose="02020603050405020304" pitchFamily="18" charset="0"/>
+              </a:rPr>
+              <a:t>Preguntas planteadas.</a:t>
+            </a:r>
+            <a:endParaRPr lang="es-ES" dirty="0">
+              <a:latin typeface="Times New Roman" panose="02020603050405020304" pitchFamily="18" charset="0"/>
+              <a:cs typeface="Times New Roman" panose="02020603050405020304" pitchFamily="18" charset="0"/>
+            </a:endParaRPr>
+          </a:p>
+        </p:txBody>
+      </p:sp>
+      <p:sp>
+        <p:nvSpPr>
+          <p:cNvPr id="3" name="Marcador de contenido 2">
+            <a:extLst>
+              <a:ext uri="{FF2B5EF4-FFF2-40B4-BE49-F238E27FC236}">
+                <a16:creationId xmlns:a16="http://schemas.microsoft.com/office/drawing/2014/main" id="{3B18F49F-1CEF-CBAF-C848-19CC8B385AE0}"/>
+              </a:ext>
+            </a:extLst>
+          </p:cNvPr>
+          <p:cNvSpPr>
+            <a:spLocks noGrp="1"/>
+          </p:cNvSpPr>
+          <p:nvPr>
+            <p:ph idx="1"/>
+          </p:nvPr>
+        </p:nvSpPr>
+        <p:spPr>
+          <a:xfrm>
+            <a:off x="838200" y="930484"/>
+            <a:ext cx="10515600" cy="4351338"/>
+          </a:xfrm>
+        </p:spPr>
+        <p:txBody>
+          <a:bodyPr>
+            <a:normAutofit/>
+          </a:bodyPr>
+          <a:lstStyle/>
+          <a:p>
+            <a:r>
+              <a:rPr lang="es-ES" sz="2400" b="0" i="0" u="none" strike="noStrike" baseline="0" dirty="0">
+                <a:latin typeface="Times New Roman" panose="02020603050405020304" pitchFamily="18" charset="0"/>
+                <a:cs typeface="Times New Roman" panose="02020603050405020304" pitchFamily="18" charset="0"/>
+              </a:rPr>
+              <a:t>¿Qué combinaciones de productos se compran con mayor frecuencia en una misma factura?</a:t>
+            </a:r>
+          </a:p>
+          <a:p>
+            <a:pPr lvl="1"/>
+            <a:endParaRPr lang="es-ES" sz="2000" dirty="0">
+              <a:latin typeface="Times New Roman" panose="02020603050405020304" pitchFamily="18" charset="0"/>
+              <a:cs typeface="Times New Roman" panose="02020603050405020304" pitchFamily="18" charset="0"/>
+            </a:endParaRPr>
+          </a:p>
+        </p:txBody>
+      </p:sp>
+      <p:sp>
+        <p:nvSpPr>
+          <p:cNvPr id="4" name="Marcador de pie de página 3">
+            <a:extLst>
+              <a:ext uri="{FF2B5EF4-FFF2-40B4-BE49-F238E27FC236}">
+                <a16:creationId xmlns:a16="http://schemas.microsoft.com/office/drawing/2014/main" id="{41B6AEC8-5B82-3602-7A88-F06CCB5CDC13}"/>
+              </a:ext>
+            </a:extLst>
+          </p:cNvPr>
+          <p:cNvSpPr>
+            <a:spLocks noGrp="1"/>
+          </p:cNvSpPr>
+          <p:nvPr>
+            <p:ph type="ftr" sz="quarter" idx="11"/>
+          </p:nvPr>
+        </p:nvSpPr>
+        <p:spPr/>
+        <p:txBody>
+          <a:bodyPr/>
+          <a:lstStyle/>
+          <a:p>
+            <a:r>
+              <a:rPr lang="es-ES"/>
+              <a:t>Mini Proyecto</a:t>
+            </a:r>
+            <a:endParaRPr lang="es-ES" dirty="0"/>
+          </a:p>
+        </p:txBody>
+      </p:sp>
+      <p:sp>
+        <p:nvSpPr>
+          <p:cNvPr id="5" name="Marcador de número de diapositiva 4">
+            <a:extLst>
+              <a:ext uri="{FF2B5EF4-FFF2-40B4-BE49-F238E27FC236}">
+                <a16:creationId xmlns:a16="http://schemas.microsoft.com/office/drawing/2014/main" id="{2E7B9A47-0243-A532-EE15-B285E747A7D1}"/>
+              </a:ext>
+            </a:extLst>
+          </p:cNvPr>
+          <p:cNvSpPr>
+            <a:spLocks noGrp="1"/>
+          </p:cNvSpPr>
+          <p:nvPr>
+            <p:ph type="sldNum" sz="quarter" idx="12"/>
+          </p:nvPr>
+        </p:nvSpPr>
+        <p:spPr/>
+        <p:txBody>
+          <a:bodyPr/>
+          <a:lstStyle/>
+          <a:p>
+            <a:fld id="{57CCFD16-40BC-4790-95C3-D9FCA59BD7C9}" type="slidenum">
+              <a:rPr lang="es-ES" smtClean="0"/>
+              <a:pPr/>
+              <a:t>10</a:t>
+            </a:fld>
+            <a:endParaRPr lang="es-ES" dirty="0"/>
+          </a:p>
+        </p:txBody>
+      </p:sp>
+      <p:pic>
+        <p:nvPicPr>
+          <p:cNvPr id="7" name="Imagen 6" descr="Gráfico, Gráfico de cajas y bigotes&#10;&#10;El contenido generado por IA puede ser incorrecto.">
+            <a:extLst>
+              <a:ext uri="{FF2B5EF4-FFF2-40B4-BE49-F238E27FC236}">
+                <a16:creationId xmlns:a16="http://schemas.microsoft.com/office/drawing/2014/main" id="{FC07CE0F-8B77-4E64-3C52-1A86D4AE09C7}"/>
+              </a:ext>
+            </a:extLst>
+          </p:cNvPr>
+          <p:cNvPicPr>
+            <a:picLocks noChangeAspect="1"/>
+          </p:cNvPicPr>
+          <p:nvPr/>
+        </p:nvPicPr>
+        <p:blipFill>
+          <a:blip r:embed="rId2">
+            <a:extLst>
+              <a:ext uri="{28A0092B-C50C-407E-A947-70E740481C1C}">
+                <a14:useLocalDpi xmlns:a14="http://schemas.microsoft.com/office/drawing/2010/main" val="0"/>
+              </a:ext>
+            </a:extLst>
+          </a:blip>
+          <a:stretch>
+            <a:fillRect/>
+          </a:stretch>
+        </p:blipFill>
+        <p:spPr>
+          <a:xfrm>
+            <a:off x="2895594" y="1657140"/>
+            <a:ext cx="4540186" cy="4540186"/>
+          </a:xfrm>
+          <a:prstGeom prst="rect">
+            <a:avLst/>
+          </a:prstGeom>
+        </p:spPr>
+      </p:pic>
+    </p:spTree>
+    <p:extLst>
+      <p:ext uri="{BB962C8B-B14F-4D97-AF65-F5344CB8AC3E}">
+        <p14:creationId xmlns:p14="http://schemas.microsoft.com/office/powerpoint/2010/main" val="2455876532"/>
+      </p:ext>
+    </p:extLst>
+  </p:cSld>
+  <p:clrMapOvr>
+    <a:masterClrMapping/>
+  </p:clrMapOvr>
+</p:sld>
+</file>
+
+<file path=ppt/slides/slide11.xml><?xml version="1.0" encoding="utf-8"?>
+<p:sld xmlns:a="http://schemas.openxmlformats.org/drawingml/2006/main" xmlns:r="http://schemas.openxmlformats.org/officeDocument/2006/relationships" xmlns:p="http://schemas.openxmlformats.org/presentationml/2006/main">
+  <p:cSld>
+    <p:spTree>
+      <p:nvGrpSpPr>
+        <p:cNvPr id="1" name=""/>
+        <p:cNvGrpSpPr/>
+        <p:nvPr/>
+      </p:nvGrpSpPr>
+      <p:grpSpPr>
+        <a:xfrm>
+          <a:off x="0" y="0"/>
+          <a:ext cx="0" cy="0"/>
+          <a:chOff x="0" y="0"/>
+          <a:chExt cx="0" cy="0"/>
+        </a:xfrm>
+      </p:grpSpPr>
+      <p:sp>
+        <p:nvSpPr>
+          <p:cNvPr id="2" name="Título 1">
+            <a:extLst>
+              <a:ext uri="{FF2B5EF4-FFF2-40B4-BE49-F238E27FC236}">
                 <a16:creationId xmlns:a16="http://schemas.microsoft.com/office/drawing/2014/main" id="{4F68F57F-E595-ACD9-C6C7-3D8CB72BC742}"/>
               </a:ext>
             </a:extLst>
@@ -4697,7 +4907,7 @@
             <a:fld id="{57CCFD16-40BC-4790-95C3-D9FCA59BD7C9}" type="slidenum">
               <a:rPr lang="es-ES" smtClean="0"/>
               <a:pPr/>
-              <a:t>10</a:t>
+              <a:t>11</a:t>
             </a:fld>
             <a:endParaRPr lang="es-ES" dirty="0"/>
           </a:p>
@@ -4788,7 +4998,7 @@
 </p:sld>
 </file>
 
-<file path=ppt/slides/slide11.xml><?xml version="1.0" encoding="utf-8"?>
+<file path=ppt/slides/slide12.xml><?xml version="1.0" encoding="utf-8"?>
 <p:sld xmlns:a="http://schemas.openxmlformats.org/drawingml/2006/main" xmlns:r="http://schemas.openxmlformats.org/officeDocument/2006/relationships" xmlns:p="http://schemas.openxmlformats.org/presentationml/2006/main">
   <p:cSld>
     <p:spTree>
@@ -4810,7 +5020,7 @@
           <p:cNvPr id="2" name="Título 1">
             <a:extLst>
               <a:ext uri="{FF2B5EF4-FFF2-40B4-BE49-F238E27FC236}">
-                <a16:creationId xmlns:a16="http://schemas.microsoft.com/office/drawing/2014/main" id="{D0C81A7F-E746-FAD9-0A5C-DDB1F9736227}"/>
+                <a16:creationId xmlns:a16="http://schemas.microsoft.com/office/drawing/2014/main" id="{2C240DA3-36E2-CBFC-255E-869FB5E0CA32}"/>
               </a:ext>
             </a:extLst>
           </p:cNvPr>
@@ -4847,6 +5057,211 @@
           <p:cNvPr id="3" name="Marcador de contenido 2">
             <a:extLst>
               <a:ext uri="{FF2B5EF4-FFF2-40B4-BE49-F238E27FC236}">
+                <a16:creationId xmlns:a16="http://schemas.microsoft.com/office/drawing/2014/main" id="{EF9A0FCD-84D6-C30A-8D27-31BDF0247104}"/>
+              </a:ext>
+            </a:extLst>
+          </p:cNvPr>
+          <p:cNvSpPr>
+            <a:spLocks noGrp="1"/>
+          </p:cNvSpPr>
+          <p:nvPr>
+            <p:ph idx="1"/>
+          </p:nvPr>
+        </p:nvSpPr>
+        <p:spPr>
+          <a:xfrm>
+            <a:off x="838200" y="1157410"/>
+            <a:ext cx="10515600" cy="4351338"/>
+          </a:xfrm>
+        </p:spPr>
+        <p:txBody>
+          <a:bodyPr>
+            <a:normAutofit/>
+          </a:bodyPr>
+          <a:lstStyle/>
+          <a:p>
+            <a:pPr algn="l"/>
+            <a:r>
+              <a:rPr lang="es-ES" sz="2400" b="0" i="0" u="none" strike="noStrike" baseline="0" dirty="0">
+                <a:latin typeface="Times New Roman" panose="02020603050405020304" pitchFamily="18" charset="0"/>
+                <a:cs typeface="Times New Roman" panose="02020603050405020304" pitchFamily="18" charset="0"/>
+              </a:rPr>
+              <a:t>¿Qué productos mantienen un volumen de ventas estable, independientemente de cambios en su precio unitario?</a:t>
+            </a:r>
+            <a:endParaRPr lang="es-ES" sz="2400" dirty="0">
+              <a:latin typeface="Times New Roman" panose="02020603050405020304" pitchFamily="18" charset="0"/>
+              <a:cs typeface="Times New Roman" panose="02020603050405020304" pitchFamily="18" charset="0"/>
+            </a:endParaRPr>
+          </a:p>
+        </p:txBody>
+      </p:sp>
+      <p:sp>
+        <p:nvSpPr>
+          <p:cNvPr id="4" name="Marcador de pie de página 3">
+            <a:extLst>
+              <a:ext uri="{FF2B5EF4-FFF2-40B4-BE49-F238E27FC236}">
+                <a16:creationId xmlns:a16="http://schemas.microsoft.com/office/drawing/2014/main" id="{9D915A5C-562C-9028-65B8-C9854FD74802}"/>
+              </a:ext>
+            </a:extLst>
+          </p:cNvPr>
+          <p:cNvSpPr>
+            <a:spLocks noGrp="1"/>
+          </p:cNvSpPr>
+          <p:nvPr>
+            <p:ph type="ftr" sz="quarter" idx="11"/>
+          </p:nvPr>
+        </p:nvSpPr>
+        <p:spPr/>
+        <p:txBody>
+          <a:bodyPr/>
+          <a:lstStyle/>
+          <a:p>
+            <a:r>
+              <a:rPr lang="es-ES"/>
+              <a:t>Mini Proyecto</a:t>
+            </a:r>
+            <a:endParaRPr lang="es-ES" dirty="0"/>
+          </a:p>
+        </p:txBody>
+      </p:sp>
+      <p:sp>
+        <p:nvSpPr>
+          <p:cNvPr id="5" name="Marcador de número de diapositiva 4">
+            <a:extLst>
+              <a:ext uri="{FF2B5EF4-FFF2-40B4-BE49-F238E27FC236}">
+                <a16:creationId xmlns:a16="http://schemas.microsoft.com/office/drawing/2014/main" id="{A53B34DB-5513-8B4D-1A4C-D419A7274DF3}"/>
+              </a:ext>
+            </a:extLst>
+          </p:cNvPr>
+          <p:cNvSpPr>
+            <a:spLocks noGrp="1"/>
+          </p:cNvSpPr>
+          <p:nvPr>
+            <p:ph type="sldNum" sz="quarter" idx="12"/>
+          </p:nvPr>
+        </p:nvSpPr>
+        <p:spPr/>
+        <p:txBody>
+          <a:bodyPr/>
+          <a:lstStyle/>
+          <a:p>
+            <a:fld id="{57CCFD16-40BC-4790-95C3-D9FCA59BD7C9}" type="slidenum">
+              <a:rPr lang="es-ES" smtClean="0"/>
+              <a:pPr/>
+              <a:t>12</a:t>
+            </a:fld>
+            <a:endParaRPr lang="es-ES" dirty="0"/>
+          </a:p>
+        </p:txBody>
+      </p:sp>
+      <p:pic>
+        <p:nvPicPr>
+          <p:cNvPr id="7" name="Imagen 6" descr="Gráfico, Diagrama, Gráfico de rectángulos&#10;&#10;El contenido generado por IA puede ser incorrecto.">
+            <a:extLst>
+              <a:ext uri="{FF2B5EF4-FFF2-40B4-BE49-F238E27FC236}">
+                <a16:creationId xmlns:a16="http://schemas.microsoft.com/office/drawing/2014/main" id="{5601022E-D22B-2E25-31A6-E07E7AEB0DB6}"/>
+              </a:ext>
+            </a:extLst>
+          </p:cNvPr>
+          <p:cNvPicPr>
+            <a:picLocks noChangeAspect="1"/>
+          </p:cNvPicPr>
+          <p:nvPr/>
+        </p:nvPicPr>
+        <p:blipFill>
+          <a:blip r:embed="rId2">
+            <a:extLst>
+              <a:ext uri="{28A0092B-C50C-407E-A947-70E740481C1C}">
+                <a14:useLocalDpi xmlns:a14="http://schemas.microsoft.com/office/drawing/2010/main" val="0"/>
+              </a:ext>
+            </a:extLst>
+          </a:blip>
+          <a:stretch>
+            <a:fillRect/>
+          </a:stretch>
+        </p:blipFill>
+        <p:spPr>
+          <a:xfrm>
+            <a:off x="4089008" y="1977086"/>
+            <a:ext cx="4013984" cy="4013984"/>
+          </a:xfrm>
+          <a:prstGeom prst="rect">
+            <a:avLst/>
+          </a:prstGeom>
+        </p:spPr>
+      </p:pic>
+    </p:spTree>
+    <p:extLst>
+      <p:ext uri="{BB962C8B-B14F-4D97-AF65-F5344CB8AC3E}">
+        <p14:creationId xmlns:p14="http://schemas.microsoft.com/office/powerpoint/2010/main" val="2558315437"/>
+      </p:ext>
+    </p:extLst>
+  </p:cSld>
+  <p:clrMapOvr>
+    <a:masterClrMapping/>
+  </p:clrMapOvr>
+</p:sld>
+</file>
+
+<file path=ppt/slides/slide13.xml><?xml version="1.0" encoding="utf-8"?>
+<p:sld xmlns:a="http://schemas.openxmlformats.org/drawingml/2006/main" xmlns:r="http://schemas.openxmlformats.org/officeDocument/2006/relationships" xmlns:p="http://schemas.openxmlformats.org/presentationml/2006/main">
+  <p:cSld>
+    <p:spTree>
+      <p:nvGrpSpPr>
+        <p:cNvPr id="1" name=""/>
+        <p:cNvGrpSpPr/>
+        <p:nvPr/>
+      </p:nvGrpSpPr>
+      <p:grpSpPr>
+        <a:xfrm>
+          <a:off x="0" y="0"/>
+          <a:ext cx="0" cy="0"/>
+          <a:chOff x="0" y="0"/>
+          <a:chExt cx="0" cy="0"/>
+        </a:xfrm>
+      </p:grpSpPr>
+      <p:sp>
+        <p:nvSpPr>
+          <p:cNvPr id="2" name="Título 1">
+            <a:extLst>
+              <a:ext uri="{FF2B5EF4-FFF2-40B4-BE49-F238E27FC236}">
+                <a16:creationId xmlns:a16="http://schemas.microsoft.com/office/drawing/2014/main" id="{D0C81A7F-E746-FAD9-0A5C-DDB1F9736227}"/>
+              </a:ext>
+            </a:extLst>
+          </p:cNvPr>
+          <p:cNvSpPr>
+            <a:spLocks noGrp="1"/>
+          </p:cNvSpPr>
+          <p:nvPr>
+            <p:ph type="title"/>
+          </p:nvPr>
+        </p:nvSpPr>
+        <p:spPr>
+          <a:xfrm>
+            <a:off x="838200" y="0"/>
+            <a:ext cx="10515600" cy="1325563"/>
+          </a:xfrm>
+        </p:spPr>
+        <p:txBody>
+          <a:bodyPr/>
+          <a:lstStyle/>
+          <a:p>
+            <a:r>
+              <a:rPr lang="es-419" dirty="0">
+                <a:latin typeface="Times New Roman" panose="02020603050405020304" pitchFamily="18" charset="0"/>
+                <a:cs typeface="Times New Roman" panose="02020603050405020304" pitchFamily="18" charset="0"/>
+              </a:rPr>
+              <a:t>Preguntas planteadas.</a:t>
+            </a:r>
+            <a:endParaRPr lang="es-ES" dirty="0"/>
+          </a:p>
+        </p:txBody>
+      </p:sp>
+      <p:sp>
+        <p:nvSpPr>
+          <p:cNvPr id="3" name="Marcador de contenido 2">
+            <a:extLst>
+              <a:ext uri="{FF2B5EF4-FFF2-40B4-BE49-F238E27FC236}">
                 <a16:creationId xmlns:a16="http://schemas.microsoft.com/office/drawing/2014/main" id="{FFA0B18F-6CF4-B930-3DB4-AAC91F6801D5}"/>
               </a:ext>
             </a:extLst>
@@ -4938,7 +5353,7 @@
             <a:fld id="{57CCFD16-40BC-4790-95C3-D9FCA59BD7C9}" type="slidenum">
               <a:rPr lang="es-ES" smtClean="0"/>
               <a:pPr/>
-              <a:t>11</a:t>
+              <a:t>13</a:t>
             </a:fld>
             <a:endParaRPr lang="es-ES" dirty="0"/>
           </a:p>
@@ -4987,7 +5402,7 @@
 </p:sld>
 </file>
 
-<file path=ppt/slides/slide12.xml><?xml version="1.0" encoding="utf-8"?>
+<file path=ppt/slides/slide14.xml><?xml version="1.0" encoding="utf-8"?>
 <p:sld xmlns:a="http://schemas.openxmlformats.org/drawingml/2006/main" xmlns:r="http://schemas.openxmlformats.org/officeDocument/2006/relationships" xmlns:p="http://schemas.openxmlformats.org/presentationml/2006/main">
   <p:cSld>
     <p:spTree>
@@ -5137,7 +5552,7 @@
             <a:fld id="{57CCFD16-40BC-4790-95C3-D9FCA59BD7C9}" type="slidenum">
               <a:rPr lang="es-ES" smtClean="0"/>
               <a:pPr/>
-              <a:t>12</a:t>
+              <a:t>14</a:t>
             </a:fld>
             <a:endParaRPr lang="es-ES" dirty="0"/>
           </a:p>
@@ -5183,415 +5598,6 @@
     <p:extLst>
       <p:ext uri="{BB962C8B-B14F-4D97-AF65-F5344CB8AC3E}">
         <p14:creationId xmlns:p14="http://schemas.microsoft.com/office/powerpoint/2010/main" val="3447622527"/>
-      </p:ext>
-    </p:extLst>
-  </p:cSld>
-  <p:clrMapOvr>
-    <a:masterClrMapping/>
-  </p:clrMapOvr>
-</p:sld>
-</file>
-
-<file path=ppt/slides/slide13.xml><?xml version="1.0" encoding="utf-8"?>
-<p:sld xmlns:a="http://schemas.openxmlformats.org/drawingml/2006/main" xmlns:r="http://schemas.openxmlformats.org/officeDocument/2006/relationships" xmlns:p="http://schemas.openxmlformats.org/presentationml/2006/main">
-  <p:cSld>
-    <p:spTree>
-      <p:nvGrpSpPr>
-        <p:cNvPr id="1" name=""/>
-        <p:cNvGrpSpPr/>
-        <p:nvPr/>
-      </p:nvGrpSpPr>
-      <p:grpSpPr>
-        <a:xfrm>
-          <a:off x="0" y="0"/>
-          <a:ext cx="0" cy="0"/>
-          <a:chOff x="0" y="0"/>
-          <a:chExt cx="0" cy="0"/>
-        </a:xfrm>
-      </p:grpSpPr>
-      <p:sp>
-        <p:nvSpPr>
-          <p:cNvPr id="2" name="Título 1">
-            <a:extLst>
-              <a:ext uri="{FF2B5EF4-FFF2-40B4-BE49-F238E27FC236}">
-                <a16:creationId xmlns:a16="http://schemas.microsoft.com/office/drawing/2014/main" id="{650B8606-ED91-07B8-C9CC-D069A6E92DFC}"/>
-              </a:ext>
-            </a:extLst>
-          </p:cNvPr>
-          <p:cNvSpPr>
-            <a:spLocks noGrp="1"/>
-          </p:cNvSpPr>
-          <p:nvPr>
-            <p:ph type="title"/>
-          </p:nvPr>
-        </p:nvSpPr>
-        <p:spPr>
-          <a:xfrm>
-            <a:off x="838200" y="0"/>
-            <a:ext cx="10515600" cy="1325563"/>
-          </a:xfrm>
-        </p:spPr>
-        <p:txBody>
-          <a:bodyPr/>
-          <a:lstStyle/>
-          <a:p>
-            <a:r>
-              <a:rPr lang="es-419" dirty="0">
-                <a:latin typeface="Times New Roman" panose="02020603050405020304" pitchFamily="18" charset="0"/>
-                <a:cs typeface="Times New Roman" panose="02020603050405020304" pitchFamily="18" charset="0"/>
-              </a:rPr>
-              <a:t>Preguntas planteadas.</a:t>
-            </a:r>
-            <a:endParaRPr lang="es-ES" dirty="0"/>
-          </a:p>
-        </p:txBody>
-      </p:sp>
-      <p:sp>
-        <p:nvSpPr>
-          <p:cNvPr id="3" name="Marcador de contenido 2">
-            <a:extLst>
-              <a:ext uri="{FF2B5EF4-FFF2-40B4-BE49-F238E27FC236}">
-                <a16:creationId xmlns:a16="http://schemas.microsoft.com/office/drawing/2014/main" id="{7AB139BA-67A8-5E40-8EE8-F2DD7C870305}"/>
-              </a:ext>
-            </a:extLst>
-          </p:cNvPr>
-          <p:cNvSpPr>
-            <a:spLocks noGrp="1"/>
-          </p:cNvSpPr>
-          <p:nvPr>
-            <p:ph idx="1"/>
-          </p:nvPr>
-        </p:nvSpPr>
-        <p:spPr>
-          <a:xfrm>
-            <a:off x="838200" y="1056088"/>
-            <a:ext cx="10515600" cy="4351338"/>
-          </a:xfrm>
-        </p:spPr>
-        <p:txBody>
-          <a:bodyPr>
-            <a:normAutofit/>
-          </a:bodyPr>
-          <a:lstStyle/>
-          <a:p>
-            <a:r>
-              <a:rPr lang="es-ES" sz="2400" b="0" i="0" u="none" strike="noStrike" baseline="0" dirty="0">
-                <a:latin typeface="Times New Roman" panose="02020603050405020304" pitchFamily="18" charset="0"/>
-                <a:cs typeface="Times New Roman" panose="02020603050405020304" pitchFamily="18" charset="0"/>
-              </a:rPr>
-              <a:t>¿Cuál es la procedencia de los tickets? ¿Qué ciudad/ pueblo tiene un mayor número de tickets?</a:t>
-            </a:r>
-            <a:endParaRPr lang="es-ES" sz="2400" dirty="0">
-              <a:latin typeface="Times New Roman" panose="02020603050405020304" pitchFamily="18" charset="0"/>
-              <a:cs typeface="Times New Roman" panose="02020603050405020304" pitchFamily="18" charset="0"/>
-            </a:endParaRPr>
-          </a:p>
-        </p:txBody>
-      </p:sp>
-      <p:sp>
-        <p:nvSpPr>
-          <p:cNvPr id="4" name="Marcador de pie de página 3">
-            <a:extLst>
-              <a:ext uri="{FF2B5EF4-FFF2-40B4-BE49-F238E27FC236}">
-                <a16:creationId xmlns:a16="http://schemas.microsoft.com/office/drawing/2014/main" id="{ACDF7CF0-1F76-FBC7-863A-B8F88C406835}"/>
-              </a:ext>
-            </a:extLst>
-          </p:cNvPr>
-          <p:cNvSpPr>
-            <a:spLocks noGrp="1"/>
-          </p:cNvSpPr>
-          <p:nvPr>
-            <p:ph type="ftr" sz="quarter" idx="11"/>
-          </p:nvPr>
-        </p:nvSpPr>
-        <p:spPr/>
-        <p:txBody>
-          <a:bodyPr/>
-          <a:lstStyle/>
-          <a:p>
-            <a:r>
-              <a:rPr lang="es-ES"/>
-              <a:t>Mini Proyecto</a:t>
-            </a:r>
-            <a:endParaRPr lang="es-ES" dirty="0"/>
-          </a:p>
-        </p:txBody>
-      </p:sp>
-      <p:sp>
-        <p:nvSpPr>
-          <p:cNvPr id="5" name="Marcador de número de diapositiva 4">
-            <a:extLst>
-              <a:ext uri="{FF2B5EF4-FFF2-40B4-BE49-F238E27FC236}">
-                <a16:creationId xmlns:a16="http://schemas.microsoft.com/office/drawing/2014/main" id="{31619FCD-55A0-EE63-4D51-5BD4F9C2325C}"/>
-              </a:ext>
-            </a:extLst>
-          </p:cNvPr>
-          <p:cNvSpPr>
-            <a:spLocks noGrp="1"/>
-          </p:cNvSpPr>
-          <p:nvPr>
-            <p:ph type="sldNum" sz="quarter" idx="12"/>
-          </p:nvPr>
-        </p:nvSpPr>
-        <p:spPr/>
-        <p:txBody>
-          <a:bodyPr/>
-          <a:lstStyle/>
-          <a:p>
-            <a:fld id="{57CCFD16-40BC-4790-95C3-D9FCA59BD7C9}" type="slidenum">
-              <a:rPr lang="es-ES" smtClean="0"/>
-              <a:pPr/>
-              <a:t>13</a:t>
-            </a:fld>
-            <a:endParaRPr lang="es-ES" dirty="0"/>
-          </a:p>
-        </p:txBody>
-      </p:sp>
-      <p:pic>
-        <p:nvPicPr>
-          <p:cNvPr id="7" name="Imagen 6" descr="Imagen que contiene Diagrama&#10;&#10;El contenido generado por IA puede ser incorrecto.">
-            <a:extLst>
-              <a:ext uri="{FF2B5EF4-FFF2-40B4-BE49-F238E27FC236}">
-                <a16:creationId xmlns:a16="http://schemas.microsoft.com/office/drawing/2014/main" id="{59D54823-76D1-FC86-6761-5C1CE737E873}"/>
-              </a:ext>
-            </a:extLst>
-          </p:cNvPr>
-          <p:cNvPicPr>
-            <a:picLocks noChangeAspect="1"/>
-          </p:cNvPicPr>
-          <p:nvPr/>
-        </p:nvPicPr>
-        <p:blipFill>
-          <a:blip r:embed="rId2">
-            <a:extLst>
-              <a:ext uri="{28A0092B-C50C-407E-A947-70E740481C1C}">
-                <a14:useLocalDpi xmlns:a14="http://schemas.microsoft.com/office/drawing/2010/main" val="0"/>
-              </a:ext>
-            </a:extLst>
-          </a:blip>
-          <a:stretch>
-            <a:fillRect/>
-          </a:stretch>
-        </p:blipFill>
-        <p:spPr>
-          <a:xfrm>
-            <a:off x="2600835" y="1518534"/>
-            <a:ext cx="4449752" cy="4449752"/>
-          </a:xfrm>
-          <a:prstGeom prst="rect">
-            <a:avLst/>
-          </a:prstGeom>
-        </p:spPr>
-      </p:pic>
-    </p:spTree>
-    <p:extLst>
-      <p:ext uri="{BB962C8B-B14F-4D97-AF65-F5344CB8AC3E}">
-        <p14:creationId xmlns:p14="http://schemas.microsoft.com/office/powerpoint/2010/main" val="2851460273"/>
-      </p:ext>
-    </p:extLst>
-  </p:cSld>
-  <p:clrMapOvr>
-    <a:masterClrMapping/>
-  </p:clrMapOvr>
-</p:sld>
-</file>
-
-<file path=ppt/slides/slide14.xml><?xml version="1.0" encoding="utf-8"?>
-<p:sld xmlns:a="http://schemas.openxmlformats.org/drawingml/2006/main" xmlns:r="http://schemas.openxmlformats.org/officeDocument/2006/relationships" xmlns:p="http://schemas.openxmlformats.org/presentationml/2006/main">
-  <p:cSld>
-    <p:spTree>
-      <p:nvGrpSpPr>
-        <p:cNvPr id="1" name=""/>
-        <p:cNvGrpSpPr/>
-        <p:nvPr/>
-      </p:nvGrpSpPr>
-      <p:grpSpPr>
-        <a:xfrm>
-          <a:off x="0" y="0"/>
-          <a:ext cx="0" cy="0"/>
-          <a:chOff x="0" y="0"/>
-          <a:chExt cx="0" cy="0"/>
-        </a:xfrm>
-      </p:grpSpPr>
-      <p:sp>
-        <p:nvSpPr>
-          <p:cNvPr id="2" name="Título 1">
-            <a:extLst>
-              <a:ext uri="{FF2B5EF4-FFF2-40B4-BE49-F238E27FC236}">
-                <a16:creationId xmlns:a16="http://schemas.microsoft.com/office/drawing/2014/main" id="{470FC65E-9122-0F11-C709-2CAF608B11DA}"/>
-              </a:ext>
-            </a:extLst>
-          </p:cNvPr>
-          <p:cNvSpPr>
-            <a:spLocks noGrp="1"/>
-          </p:cNvSpPr>
-          <p:nvPr>
-            <p:ph type="title"/>
-          </p:nvPr>
-        </p:nvSpPr>
-        <p:spPr>
-          <a:xfrm>
-            <a:off x="838200" y="-190919"/>
-            <a:ext cx="10515600" cy="1325563"/>
-          </a:xfrm>
-        </p:spPr>
-        <p:txBody>
-          <a:bodyPr/>
-          <a:lstStyle/>
-          <a:p>
-            <a:r>
-              <a:rPr lang="es-419" dirty="0">
-                <a:latin typeface="Times New Roman" panose="02020603050405020304" pitchFamily="18" charset="0"/>
-                <a:cs typeface="Times New Roman" panose="02020603050405020304" pitchFamily="18" charset="0"/>
-              </a:rPr>
-              <a:t>Preguntas planteadas.</a:t>
-            </a:r>
-            <a:endParaRPr lang="es-ES" dirty="0"/>
-          </a:p>
-        </p:txBody>
-      </p:sp>
-      <p:sp>
-        <p:nvSpPr>
-          <p:cNvPr id="3" name="Marcador de contenido 2">
-            <a:extLst>
-              <a:ext uri="{FF2B5EF4-FFF2-40B4-BE49-F238E27FC236}">
-                <a16:creationId xmlns:a16="http://schemas.microsoft.com/office/drawing/2014/main" id="{6BDA08F0-32D6-7BB1-8676-1C4DBAD84093}"/>
-              </a:ext>
-            </a:extLst>
-          </p:cNvPr>
-          <p:cNvSpPr>
-            <a:spLocks noGrp="1"/>
-          </p:cNvSpPr>
-          <p:nvPr>
-            <p:ph idx="1"/>
-          </p:nvPr>
-        </p:nvSpPr>
-        <p:spPr>
-          <a:xfrm>
-            <a:off x="838200" y="818278"/>
-            <a:ext cx="10515600" cy="4351338"/>
-          </a:xfrm>
-        </p:spPr>
-        <p:txBody>
-          <a:bodyPr>
-            <a:normAutofit/>
-          </a:bodyPr>
-          <a:lstStyle/>
-          <a:p>
-            <a:pPr algn="l"/>
-            <a:r>
-              <a:rPr lang="es-ES" sz="2400" b="0" i="0" u="none" strike="noStrike" baseline="0" dirty="0">
-                <a:latin typeface="Times New Roman" panose="02020603050405020304" pitchFamily="18" charset="0"/>
-                <a:cs typeface="Times New Roman" panose="02020603050405020304" pitchFamily="18" charset="0"/>
-              </a:rPr>
-              <a:t>Muestra mediante un diagrama el número de tickets recogidos cada día de las semana. ¿Si tuvieses que cerrar un día entre semana qué día lo harías?</a:t>
-            </a:r>
-            <a:endParaRPr lang="es-ES" sz="2400" dirty="0">
-              <a:latin typeface="Times New Roman" panose="02020603050405020304" pitchFamily="18" charset="0"/>
-              <a:cs typeface="Times New Roman" panose="02020603050405020304" pitchFamily="18" charset="0"/>
-            </a:endParaRPr>
-          </a:p>
-        </p:txBody>
-      </p:sp>
-      <p:sp>
-        <p:nvSpPr>
-          <p:cNvPr id="4" name="Marcador de pie de página 3">
-            <a:extLst>
-              <a:ext uri="{FF2B5EF4-FFF2-40B4-BE49-F238E27FC236}">
-                <a16:creationId xmlns:a16="http://schemas.microsoft.com/office/drawing/2014/main" id="{C8122CA9-CEFB-A8C3-A381-9132870E6197}"/>
-              </a:ext>
-            </a:extLst>
-          </p:cNvPr>
-          <p:cNvSpPr>
-            <a:spLocks noGrp="1"/>
-          </p:cNvSpPr>
-          <p:nvPr>
-            <p:ph type="ftr" sz="quarter" idx="11"/>
-          </p:nvPr>
-        </p:nvSpPr>
-        <p:spPr/>
-        <p:txBody>
-          <a:bodyPr/>
-          <a:lstStyle/>
-          <a:p>
-            <a:r>
-              <a:rPr lang="es-ES"/>
-              <a:t>Mini Proyecto</a:t>
-            </a:r>
-            <a:endParaRPr lang="es-ES" dirty="0"/>
-          </a:p>
-        </p:txBody>
-      </p:sp>
-      <p:sp>
-        <p:nvSpPr>
-          <p:cNvPr id="5" name="Marcador de número de diapositiva 4">
-            <a:extLst>
-              <a:ext uri="{FF2B5EF4-FFF2-40B4-BE49-F238E27FC236}">
-                <a16:creationId xmlns:a16="http://schemas.microsoft.com/office/drawing/2014/main" id="{0B68B907-2033-D076-C1BE-DCAE9C888532}"/>
-              </a:ext>
-            </a:extLst>
-          </p:cNvPr>
-          <p:cNvSpPr>
-            <a:spLocks noGrp="1"/>
-          </p:cNvSpPr>
-          <p:nvPr>
-            <p:ph type="sldNum" sz="quarter" idx="12"/>
-          </p:nvPr>
-        </p:nvSpPr>
-        <p:spPr/>
-        <p:txBody>
-          <a:bodyPr/>
-          <a:lstStyle/>
-          <a:p>
-            <a:fld id="{57CCFD16-40BC-4790-95C3-D9FCA59BD7C9}" type="slidenum">
-              <a:rPr lang="es-ES" smtClean="0"/>
-              <a:pPr/>
-              <a:t>14</a:t>
-            </a:fld>
-            <a:endParaRPr lang="es-ES" dirty="0"/>
-          </a:p>
-        </p:txBody>
-      </p:sp>
-      <p:pic>
-        <p:nvPicPr>
-          <p:cNvPr id="7" name="Imagen 6" descr="Gráfico, Gráfico de barras&#10;&#10;El contenido generado por IA puede ser incorrecto.">
-            <a:extLst>
-              <a:ext uri="{FF2B5EF4-FFF2-40B4-BE49-F238E27FC236}">
-                <a16:creationId xmlns:a16="http://schemas.microsoft.com/office/drawing/2014/main" id="{25E9E832-A342-DD7E-0AA2-F6388882F589}"/>
-              </a:ext>
-            </a:extLst>
-          </p:cNvPr>
-          <p:cNvPicPr>
-            <a:picLocks noChangeAspect="1"/>
-          </p:cNvPicPr>
-          <p:nvPr/>
-        </p:nvPicPr>
-        <p:blipFill>
-          <a:blip r:embed="rId2">
-            <a:extLst>
-              <a:ext uri="{28A0092B-C50C-407E-A947-70E740481C1C}">
-                <a14:useLocalDpi xmlns:a14="http://schemas.microsoft.com/office/drawing/2010/main" val="0"/>
-              </a:ext>
-            </a:extLst>
-          </a:blip>
-          <a:stretch>
-            <a:fillRect/>
-          </a:stretch>
-        </p:blipFill>
-        <p:spPr>
-          <a:xfrm>
-            <a:off x="2823935" y="1899652"/>
-            <a:ext cx="6544130" cy="4039586"/>
-          </a:xfrm>
-          <a:prstGeom prst="rect">
-            <a:avLst/>
-          </a:prstGeom>
-        </p:spPr>
-      </p:pic>
-    </p:spTree>
-    <p:extLst>
-      <p:ext uri="{BB962C8B-B14F-4D97-AF65-F5344CB8AC3E}">
-        <p14:creationId xmlns:p14="http://schemas.microsoft.com/office/powerpoint/2010/main" val="118555930"/>
       </p:ext>
     </p:extLst>
   </p:cSld>
@@ -6296,7 +6302,7 @@
           <p:cNvPr id="2" name="Título 1">
             <a:extLst>
               <a:ext uri="{FF2B5EF4-FFF2-40B4-BE49-F238E27FC236}">
-                <a16:creationId xmlns:a16="http://schemas.microsoft.com/office/drawing/2014/main" id="{E6B63943-A4BA-B93C-B1BB-37552196A028}"/>
+                <a16:creationId xmlns:a16="http://schemas.microsoft.com/office/drawing/2014/main" id="{650B8606-ED91-07B8-C9CC-D069A6E92DFC}"/>
               </a:ext>
             </a:extLst>
           </p:cNvPr>
@@ -6309,7 +6315,7 @@
         </p:nvSpPr>
         <p:spPr>
           <a:xfrm>
-            <a:off x="838200" y="-133907"/>
+            <a:off x="838200" y="0"/>
             <a:ext cx="10515600" cy="1325563"/>
           </a:xfrm>
         </p:spPr>
@@ -6324,10 +6330,7 @@
               </a:rPr>
               <a:t>Preguntas planteadas.</a:t>
             </a:r>
-            <a:endParaRPr lang="es-ES" dirty="0">
-              <a:latin typeface="Times New Roman" panose="02020603050405020304" pitchFamily="18" charset="0"/>
-              <a:cs typeface="Times New Roman" panose="02020603050405020304" pitchFamily="18" charset="0"/>
-            </a:endParaRPr>
+            <a:endParaRPr lang="es-ES" dirty="0"/>
           </a:p>
         </p:txBody>
       </p:sp>
@@ -6336,7 +6339,7 @@
           <p:cNvPr id="3" name="Marcador de contenido 2">
             <a:extLst>
               <a:ext uri="{FF2B5EF4-FFF2-40B4-BE49-F238E27FC236}">
-                <a16:creationId xmlns:a16="http://schemas.microsoft.com/office/drawing/2014/main" id="{3B18F49F-1CEF-CBAF-C848-19CC8B385AE0}"/>
+                <a16:creationId xmlns:a16="http://schemas.microsoft.com/office/drawing/2014/main" id="{7AB139BA-67A8-5E40-8EE8-F2DD7C870305}"/>
               </a:ext>
             </a:extLst>
           </p:cNvPr>
@@ -6349,7 +6352,7 @@
         </p:nvSpPr>
         <p:spPr>
           <a:xfrm>
-            <a:off x="838200" y="930484"/>
+            <a:off x="838200" y="1056088"/>
             <a:ext cx="10515600" cy="4351338"/>
           </a:xfrm>
         </p:spPr>
@@ -6364,12 +6367,9 @@
                 <a:latin typeface="Times New Roman" panose="02020603050405020304" pitchFamily="18" charset="0"/>
                 <a:cs typeface="Times New Roman" panose="02020603050405020304" pitchFamily="18" charset="0"/>
               </a:rPr>
-              <a:t>¿Qué combinaciones de productos se compran con mayor frecuencia en una misma factura?</a:t>
-            </a:r>
-          </a:p>
-          <a:p>
-            <a:pPr lvl="1"/>
-            <a:endParaRPr lang="es-ES" sz="2000" dirty="0">
+              <a:t>¿Cuál es la procedencia de los tickets? ¿Qué ciudad/ pueblo tiene un mayor número de tickets?</a:t>
+            </a:r>
+            <a:endParaRPr lang="es-ES" sz="2400" dirty="0">
               <a:latin typeface="Times New Roman" panose="02020603050405020304" pitchFamily="18" charset="0"/>
               <a:cs typeface="Times New Roman" panose="02020603050405020304" pitchFamily="18" charset="0"/>
             </a:endParaRPr>
@@ -6381,7 +6381,7 @@
           <p:cNvPr id="4" name="Marcador de pie de página 3">
             <a:extLst>
               <a:ext uri="{FF2B5EF4-FFF2-40B4-BE49-F238E27FC236}">
-                <a16:creationId xmlns:a16="http://schemas.microsoft.com/office/drawing/2014/main" id="{41B6AEC8-5B82-3602-7A88-F06CCB5CDC13}"/>
+                <a16:creationId xmlns:a16="http://schemas.microsoft.com/office/drawing/2014/main" id="{ACDF7CF0-1F76-FBC7-863A-B8F88C406835}"/>
               </a:ext>
             </a:extLst>
           </p:cNvPr>
@@ -6410,7 +6410,7 @@
           <p:cNvPr id="5" name="Marcador de número de diapositiva 4">
             <a:extLst>
               <a:ext uri="{FF2B5EF4-FFF2-40B4-BE49-F238E27FC236}">
-                <a16:creationId xmlns:a16="http://schemas.microsoft.com/office/drawing/2014/main" id="{2E7B9A47-0243-A532-EE15-B285E747A7D1}"/>
+                <a16:creationId xmlns:a16="http://schemas.microsoft.com/office/drawing/2014/main" id="{31619FCD-55A0-EE63-4D51-5BD4F9C2325C}"/>
               </a:ext>
             </a:extLst>
           </p:cNvPr>
@@ -6437,10 +6437,10 @@
       </p:sp>
       <p:pic>
         <p:nvPicPr>
-          <p:cNvPr id="7" name="Imagen 6" descr="Gráfico, Gráfico de cajas y bigotes&#10;&#10;El contenido generado por IA puede ser incorrecto.">
-            <a:extLst>
-              <a:ext uri="{FF2B5EF4-FFF2-40B4-BE49-F238E27FC236}">
-                <a16:creationId xmlns:a16="http://schemas.microsoft.com/office/drawing/2014/main" id="{FC07CE0F-8B77-4E64-3C52-1A86D4AE09C7}"/>
+          <p:cNvPr id="7" name="Imagen 6" descr="Imagen que contiene Diagrama&#10;&#10;El contenido generado por IA puede ser incorrecto.">
+            <a:extLst>
+              <a:ext uri="{FF2B5EF4-FFF2-40B4-BE49-F238E27FC236}">
+                <a16:creationId xmlns:a16="http://schemas.microsoft.com/office/drawing/2014/main" id="{59D54823-76D1-FC86-6761-5C1CE737E873}"/>
               </a:ext>
             </a:extLst>
           </p:cNvPr>
@@ -6463,8 +6463,8 @@
         </p:blipFill>
         <p:spPr>
           <a:xfrm>
-            <a:off x="2895594" y="1657140"/>
-            <a:ext cx="4540186" cy="4540186"/>
+            <a:off x="2600835" y="1518534"/>
+            <a:ext cx="4449752" cy="4449752"/>
           </a:xfrm>
           <a:prstGeom prst="rect">
             <a:avLst/>
@@ -6474,7 +6474,7 @@
     </p:spTree>
     <p:extLst>
       <p:ext uri="{BB962C8B-B14F-4D97-AF65-F5344CB8AC3E}">
-        <p14:creationId xmlns:p14="http://schemas.microsoft.com/office/powerpoint/2010/main" val="2455876532"/>
+        <p14:creationId xmlns:p14="http://schemas.microsoft.com/office/powerpoint/2010/main" val="2851460273"/>
       </p:ext>
     </p:extLst>
   </p:cSld>
@@ -6506,7 +6506,7 @@
           <p:cNvPr id="2" name="Título 1">
             <a:extLst>
               <a:ext uri="{FF2B5EF4-FFF2-40B4-BE49-F238E27FC236}">
-                <a16:creationId xmlns:a16="http://schemas.microsoft.com/office/drawing/2014/main" id="{2C240DA3-36E2-CBFC-255E-869FB5E0CA32}"/>
+                <a16:creationId xmlns:a16="http://schemas.microsoft.com/office/drawing/2014/main" id="{470FC65E-9122-0F11-C709-2CAF608B11DA}"/>
               </a:ext>
             </a:extLst>
           </p:cNvPr>
@@ -6519,7 +6519,7 @@
         </p:nvSpPr>
         <p:spPr>
           <a:xfrm>
-            <a:off x="838200" y="0"/>
+            <a:off x="838200" y="-190919"/>
             <a:ext cx="10515600" cy="1325563"/>
           </a:xfrm>
         </p:spPr>
@@ -6543,7 +6543,7 @@
           <p:cNvPr id="3" name="Marcador de contenido 2">
             <a:extLst>
               <a:ext uri="{FF2B5EF4-FFF2-40B4-BE49-F238E27FC236}">
-                <a16:creationId xmlns:a16="http://schemas.microsoft.com/office/drawing/2014/main" id="{EF9A0FCD-84D6-C30A-8D27-31BDF0247104}"/>
+                <a16:creationId xmlns:a16="http://schemas.microsoft.com/office/drawing/2014/main" id="{6BDA08F0-32D6-7BB1-8676-1C4DBAD84093}"/>
               </a:ext>
             </a:extLst>
           </p:cNvPr>
@@ -6556,7 +6556,7 @@
         </p:nvSpPr>
         <p:spPr>
           <a:xfrm>
-            <a:off x="838200" y="1157410"/>
+            <a:off x="838200" y="818278"/>
             <a:ext cx="10515600" cy="4351338"/>
           </a:xfrm>
         </p:spPr>
@@ -6572,7 +6572,7 @@
                 <a:latin typeface="Times New Roman" panose="02020603050405020304" pitchFamily="18" charset="0"/>
                 <a:cs typeface="Times New Roman" panose="02020603050405020304" pitchFamily="18" charset="0"/>
               </a:rPr>
-              <a:t>¿Qué productos mantienen un volumen de ventas estable, independientemente de cambios en su precio unitario?</a:t>
+              <a:t>Muestra mediante un diagrama el número de tickets recogidos cada día de las semanas. ¿Si tuvieses que cerrar un día entre semana qué día lo harías?</a:t>
             </a:r>
             <a:endParaRPr lang="es-ES" sz="2400" dirty="0">
               <a:latin typeface="Times New Roman" panose="02020603050405020304" pitchFamily="18" charset="0"/>
@@ -6586,7 +6586,7 @@
           <p:cNvPr id="4" name="Marcador de pie de página 3">
             <a:extLst>
               <a:ext uri="{FF2B5EF4-FFF2-40B4-BE49-F238E27FC236}">
-                <a16:creationId xmlns:a16="http://schemas.microsoft.com/office/drawing/2014/main" id="{9D915A5C-562C-9028-65B8-C9854FD74802}"/>
+                <a16:creationId xmlns:a16="http://schemas.microsoft.com/office/drawing/2014/main" id="{C8122CA9-CEFB-A8C3-A381-9132870E6197}"/>
               </a:ext>
             </a:extLst>
           </p:cNvPr>
@@ -6615,7 +6615,7 @@
           <p:cNvPr id="5" name="Marcador de número de diapositiva 4">
             <a:extLst>
               <a:ext uri="{FF2B5EF4-FFF2-40B4-BE49-F238E27FC236}">
-                <a16:creationId xmlns:a16="http://schemas.microsoft.com/office/drawing/2014/main" id="{A53B34DB-5513-8B4D-1A4C-D419A7274DF3}"/>
+                <a16:creationId xmlns:a16="http://schemas.microsoft.com/office/drawing/2014/main" id="{0B68B907-2033-D076-C1BE-DCAE9C888532}"/>
               </a:ext>
             </a:extLst>
           </p:cNvPr>
@@ -6642,10 +6642,10 @@
       </p:sp>
       <p:pic>
         <p:nvPicPr>
-          <p:cNvPr id="7" name="Imagen 6" descr="Gráfico, Diagrama, Gráfico de rectángulos&#10;&#10;El contenido generado por IA puede ser incorrecto.">
-            <a:extLst>
-              <a:ext uri="{FF2B5EF4-FFF2-40B4-BE49-F238E27FC236}">
-                <a16:creationId xmlns:a16="http://schemas.microsoft.com/office/drawing/2014/main" id="{5601022E-D22B-2E25-31A6-E07E7AEB0DB6}"/>
+          <p:cNvPr id="7" name="Imagen 6" descr="Gráfico, Gráfico de barras&#10;&#10;El contenido generado por IA puede ser incorrecto.">
+            <a:extLst>
+              <a:ext uri="{FF2B5EF4-FFF2-40B4-BE49-F238E27FC236}">
+                <a16:creationId xmlns:a16="http://schemas.microsoft.com/office/drawing/2014/main" id="{25E9E832-A342-DD7E-0AA2-F6388882F589}"/>
               </a:ext>
             </a:extLst>
           </p:cNvPr>
@@ -6668,8 +6668,8 @@
         </p:blipFill>
         <p:spPr>
           <a:xfrm>
-            <a:off x="4089008" y="1977086"/>
-            <a:ext cx="4013984" cy="4013984"/>
+            <a:off x="2823935" y="1899652"/>
+            <a:ext cx="6544130" cy="4039586"/>
           </a:xfrm>
           <a:prstGeom prst="rect">
             <a:avLst/>
@@ -6679,7 +6679,7 @@
     </p:spTree>
     <p:extLst>
       <p:ext uri="{BB962C8B-B14F-4D97-AF65-F5344CB8AC3E}">
-        <p14:creationId xmlns:p14="http://schemas.microsoft.com/office/powerpoint/2010/main" val="2558315437"/>
+        <p14:creationId xmlns:p14="http://schemas.microsoft.com/office/powerpoint/2010/main" val="118555930"/>
       </p:ext>
     </p:extLst>
   </p:cSld>

</xml_diff>